<commit_message>
summary of vid2world & gamefactory
</commit_message>
<xml_diff>
--- a/summary/VLL_Summary.pptx
+++ b/summary/VLL_Summary.pptx
@@ -6922,45 +6922,9 @@
             </a:endParaRPr>
           </a:p>
           <a:p>
-            <a:pPr lvl="1" indent="-317500">
+            <a:pPr marL="596900" lvl="1" indent="0">
               <a:buSzPct val="100000"/>
-            </a:pPr>
-            <a:r>
-              <a:rPr lang="en-US" altLang="zh-TW" sz="1200" dirty="0"/>
-              <a:t>Typical video diffusion models generate frames using bidirectional temporal context, allowing </a:t>
-            </a:r>
-            <a:r>
-              <a:rPr lang="en-US" altLang="zh-TW" sz="1200" dirty="0">
-                <a:solidFill>
-                  <a:schemeClr val="accent1">
-                    <a:lumMod val="50000"/>
-                  </a:schemeClr>
-                </a:solidFill>
-              </a:rPr>
-              <a:t>future frames to influence the past</a:t>
-            </a:r>
-            <a:r>
-              <a:rPr lang="en-US" altLang="zh-TW" sz="1200" dirty="0">
-                <a:solidFill>
-                  <a:schemeClr val="tx1">
-                    <a:lumMod val="95000"/>
-                    <a:lumOff val="5000"/>
-                  </a:schemeClr>
-                </a:solidFill>
-              </a:rPr>
-              <a:t>, which is undesired for world model</a:t>
-            </a:r>
-            <a:endParaRPr lang="en-US" altLang="zh-TW" sz="1200" dirty="0">
-              <a:solidFill>
-                <a:schemeClr val="accent1">
-                  <a:lumMod val="50000"/>
-                </a:schemeClr>
-              </a:solidFill>
-            </a:endParaRPr>
-          </a:p>
-          <a:p>
-            <a:pPr lvl="1" indent="-317500">
-              <a:buSzPct val="100000"/>
+              <a:buNone/>
             </a:pPr>
             <a:endParaRPr lang="en-US" sz="1400" b="1" dirty="0"/>
           </a:p>
@@ -6982,36 +6946,6 @@
               <a:rPr lang="en-US" sz="1400" b="1" dirty="0"/>
               <a:t>Lack of action conditioning</a:t>
             </a:r>
-          </a:p>
-          <a:p>
-            <a:pPr lvl="1" indent="-317500">
-              <a:buSzPct val="100000"/>
-              <a:buFont typeface="Calibri" panose="020F0502020204030204" pitchFamily="34" charset="0"/>
-              <a:buChar char="○"/>
-            </a:pPr>
-            <a:r>
-              <a:rPr lang="en-US" altLang="zh-TW" sz="1200" dirty="0">
-                <a:solidFill>
-                  <a:schemeClr val="tx1"/>
-                </a:solidFill>
-              </a:rPr>
-              <a:t>These models are typically conditioned on coarse, video-level inputs (e.g., text prompts) and </a:t>
-            </a:r>
-            <a:r>
-              <a:rPr lang="en-US" altLang="zh-TW" sz="1200" dirty="0">
-                <a:solidFill>
-                  <a:schemeClr val="accent1">
-                    <a:lumMod val="50000"/>
-                  </a:schemeClr>
-                </a:solidFill>
-              </a:rPr>
-              <a:t>lack mechanisms for fine-grained, frame-level action conditioning</a:t>
-            </a:r>
-            <a:endParaRPr lang="en-US" sz="1200" dirty="0">
-              <a:solidFill>
-                <a:schemeClr val="tx1"/>
-              </a:solidFill>
-            </a:endParaRPr>
           </a:p>
         </p:txBody>
       </p:sp>
@@ -7037,7 +6971,7 @@
         </p:blipFill>
         <p:spPr>
           <a:xfrm>
-            <a:off x="800246" y="3051313"/>
+            <a:off x="800246" y="2574698"/>
             <a:ext cx="6305550" cy="1644927"/>
           </a:xfrm>
           <a:prstGeom prst="rect">
@@ -7151,56 +7085,6 @@
           </a:bodyPr>
           <a:lstStyle/>
           <a:p>
-            <a:pPr indent="-317500">
-              <a:buSzPts val="1400"/>
-            </a:pPr>
-            <a:r>
-              <a:rPr lang="en-US" altLang="zh-TW" sz="1400" b="1" dirty="0"/>
-              <a:t>Temporal Attention Layers</a:t>
-            </a:r>
-          </a:p>
-          <a:p>
-            <a:pPr lvl="1" indent="-317500">
-              <a:buSzPct val="100000"/>
-            </a:pPr>
-            <a:r>
-              <a:rPr lang="en-US" altLang="zh-TW" sz="1200" dirty="0">
-                <a:solidFill>
-                  <a:schemeClr val="accent1">
-                    <a:lumMod val="50000"/>
-                  </a:schemeClr>
-                </a:solidFill>
-              </a:rPr>
-              <a:t>Applying causal mask </a:t>
-            </a:r>
-            <a:r>
-              <a:rPr lang="en-US" altLang="zh-TW" sz="1200" dirty="0">
-                <a:solidFill>
-                  <a:schemeClr val="tx1"/>
-                </a:solidFill>
-              </a:rPr>
-              <a:t>(below detail isn’t mentioned in this paper)</a:t>
-            </a:r>
-          </a:p>
-          <a:p>
-            <a:pPr lvl="1" indent="-317500">
-              <a:buSzPct val="100000"/>
-            </a:pPr>
-            <a:endParaRPr lang="en-US" sz="1400" b="1" dirty="0"/>
-          </a:p>
-          <a:p>
-            <a:pPr lvl="1" indent="-317500">
-              <a:buSzPct val="100000"/>
-            </a:pPr>
-            <a:endParaRPr lang="en-US" sz="1400" b="1" dirty="0"/>
-          </a:p>
-          <a:p>
-            <a:pPr lvl="1" indent="-317500">
-              <a:buSzPct val="100000"/>
-            </a:pPr>
-            <a:endParaRPr lang="en-US" sz="1400" b="1" dirty="0"/>
-          </a:p>
-          <a:p>
             <a:pPr lvl="1" indent="-317500">
               <a:buSzPct val="100000"/>
             </a:pPr>
@@ -7273,83 +7157,9 @@
             </a:endParaRPr>
           </a:p>
           <a:p>
-            <a:pPr lvl="1" indent="-317500">
+            <a:pPr marL="596900" lvl="1" indent="0">
               <a:buSzPct val="100000"/>
-              <a:buFont typeface="Calibri" panose="020F0502020204030204" pitchFamily="34" charset="0"/>
-              <a:buChar char="○"/>
-            </a:pPr>
-            <a:endParaRPr lang="en-US" sz="1200" dirty="0">
-              <a:solidFill>
-                <a:schemeClr val="tx1"/>
-              </a:solidFill>
-            </a:endParaRPr>
-          </a:p>
-          <a:p>
-            <a:pPr lvl="1" indent="-317500">
-              <a:buSzPct val="100000"/>
-              <a:buFont typeface="Calibri" panose="020F0502020204030204" pitchFamily="34" charset="0"/>
-              <a:buChar char="○"/>
-            </a:pPr>
-            <a:endParaRPr lang="en-US" sz="1200" dirty="0">
-              <a:solidFill>
-                <a:schemeClr val="tx1"/>
-              </a:solidFill>
-            </a:endParaRPr>
-          </a:p>
-          <a:p>
-            <a:pPr marL="457200" lvl="0" indent="-317500" algn="l" rtl="0">
-              <a:spcBef>
-                <a:spcPts val="0"/>
-              </a:spcBef>
-              <a:spcAft>
-                <a:spcPts val="0"/>
-              </a:spcAft>
-              <a:buClr>
-                <a:schemeClr val="dk1"/>
-              </a:buClr>
-              <a:buSzPts val="1400"/>
-              <a:buChar char="●"/>
-            </a:pPr>
-            <a:r>
-              <a:rPr lang="en-US" altLang="zh-TW" sz="1400" b="1" dirty="0"/>
-              <a:t>Diffusion forcing</a:t>
-            </a:r>
-          </a:p>
-          <a:p>
-            <a:pPr lvl="1" indent="-317500">
-              <a:buSzPct val="100000"/>
-              <a:buFont typeface="Calibri" panose="020F0502020204030204" pitchFamily="34" charset="0"/>
-              <a:buChar char="○"/>
-            </a:pPr>
-            <a:r>
-              <a:rPr lang="en-US" altLang="zh-TW" sz="1200" dirty="0">
-                <a:solidFill>
-                  <a:schemeClr val="tx1"/>
-                </a:solidFill>
-              </a:rPr>
-              <a:t>Model trained with all combination of noise levels in history frames</a:t>
-            </a:r>
-          </a:p>
-          <a:p>
-            <a:pPr lvl="1" indent="-317500">
-              <a:buSzPct val="100000"/>
-              <a:buFont typeface="Calibri" panose="020F0502020204030204" pitchFamily="34" charset="0"/>
-              <a:buChar char="○"/>
-            </a:pPr>
-            <a:r>
-              <a:rPr lang="en-US" altLang="zh-TW" sz="1200" dirty="0">
-                <a:solidFill>
-                  <a:schemeClr val="tx1"/>
-                </a:solidFill>
-              </a:rPr>
-              <a:t>Model inference with clean history and denoising current frame</a:t>
-            </a:r>
-          </a:p>
-          <a:p>
-            <a:pPr lvl="1" indent="-317500">
-              <a:buSzPct val="100000"/>
-              <a:buFont typeface="Calibri" panose="020F0502020204030204" pitchFamily="34" charset="0"/>
-              <a:buChar char="○"/>
+              <a:buNone/>
             </a:pPr>
             <a:endParaRPr lang="en-US" sz="1200" dirty="0">
               <a:solidFill>
@@ -7381,7 +7191,7 @@
         </p:blipFill>
         <p:spPr>
           <a:xfrm>
-            <a:off x="1215009" y="3176490"/>
+            <a:off x="1204961" y="2030931"/>
             <a:ext cx="2738827" cy="540819"/>
           </a:xfrm>
           <a:prstGeom prst="rect">
@@ -7411,68 +7221,8 @@
         </p:blipFill>
         <p:spPr>
           <a:xfrm>
-            <a:off x="5333816" y="1753136"/>
-            <a:ext cx="3528559" cy="1964173"/>
-          </a:xfrm>
-          <a:prstGeom prst="rect">
-            <a:avLst/>
-          </a:prstGeom>
-        </p:spPr>
-      </p:pic>
-      <p:pic>
-        <p:nvPicPr>
-          <p:cNvPr id="8" name="圖片 7">
-            <a:extLst>
-              <a:ext uri="{FF2B5EF4-FFF2-40B4-BE49-F238E27FC236}">
-                <a16:creationId xmlns:a16="http://schemas.microsoft.com/office/drawing/2014/main" id="{5A5B7CE6-B0D7-4317-912E-B40D873FCF24}"/>
-              </a:ext>
-            </a:extLst>
-          </p:cNvPr>
-          <p:cNvPicPr>
-            <a:picLocks noChangeAspect="1"/>
-          </p:cNvPicPr>
-          <p:nvPr/>
-        </p:nvPicPr>
-        <p:blipFill>
-          <a:blip r:embed="rId5"/>
-          <a:stretch>
-            <a:fillRect/>
-          </a:stretch>
-        </p:blipFill>
-        <p:spPr>
-          <a:xfrm>
-            <a:off x="1215009" y="1465632"/>
-            <a:ext cx="2681677" cy="475118"/>
-          </a:xfrm>
-          <a:prstGeom prst="rect">
-            <a:avLst/>
-          </a:prstGeom>
-        </p:spPr>
-      </p:pic>
-      <p:pic>
-        <p:nvPicPr>
-          <p:cNvPr id="10" name="圖片 9">
-            <a:extLst>
-              <a:ext uri="{FF2B5EF4-FFF2-40B4-BE49-F238E27FC236}">
-                <a16:creationId xmlns:a16="http://schemas.microsoft.com/office/drawing/2014/main" id="{140B80BF-0862-4E4D-8CFB-490A50C7BA83}"/>
-              </a:ext>
-            </a:extLst>
-          </p:cNvPr>
-          <p:cNvPicPr>
-            <a:picLocks noChangeAspect="1"/>
-          </p:cNvPicPr>
-          <p:nvPr/>
-        </p:nvPicPr>
-        <p:blipFill>
-          <a:blip r:embed="rId6"/>
-          <a:stretch>
-            <a:fillRect/>
-          </a:stretch>
-        </p:blipFill>
-        <p:spPr>
-          <a:xfrm>
-            <a:off x="1272159" y="1940750"/>
-            <a:ext cx="2681677" cy="489275"/>
+            <a:off x="4112517" y="1685445"/>
+            <a:ext cx="4552554" cy="2534180"/>
           </a:xfrm>
           <a:prstGeom prst="rect">
             <a:avLst/>
@@ -7572,26 +7322,7 @@
               </a:bodyPr>
               <a:lstStyle/>
               <a:p>
-                <a:pPr indent="-317500">
-                  <a:buSzPts val="1400"/>
-                </a:pPr>
-                <a:r>
-                  <a:rPr lang="en-US" altLang="zh-TW" sz="1400" b="1" dirty="0"/>
-                  <a:t>Previous methods</a:t>
-                </a:r>
-              </a:p>
-              <a:p>
-                <a:pPr lvl="1" indent="-317500">
-                  <a:buSzPct val="100000"/>
-                </a:pPr>
-                <a:r>
-                  <a:rPr lang="en-US" altLang="zh-TW" sz="1200" dirty="0"/>
-                  <a:t>Integrating action condition through video-level condition, where the entire action sequence is encoded to a single embedding.</a:t>
-                </a:r>
-                <a:endParaRPr lang="en-US" altLang="zh-TW" sz="1200" b="1" dirty="0"/>
-              </a:p>
-              <a:p>
-                <a:pPr marL="457200" lvl="0" indent="-317500" algn="l" rtl="0">
+                <a:pPr marL="139700" lvl="0" indent="0" algn="l" rtl="0">
                   <a:spcBef>
                     <a:spcPts val="0"/>
                   </a:spcBef>
@@ -7602,7 +7333,7 @@
                     <a:schemeClr val="dk1"/>
                   </a:buClr>
                   <a:buSzPts val="1400"/>
-                  <a:buChar char="●"/>
+                  <a:buNone/>
                 </a:pPr>
                 <a:endParaRPr lang="en-US" sz="1400" b="1" dirty="0"/>
               </a:p>
@@ -7783,7 +7514,7 @@
               <a:blipFill>
                 <a:blip r:embed="rId3"/>
                 <a:stretch>
-                  <a:fillRect r="-143"/>
+                  <a:fillRect r="-149"/>
                 </a:stretch>
               </a:blipFill>
             </p:spPr>
@@ -7832,137 +7563,6 @@
           </a:prstGeom>
         </p:spPr>
       </p:pic>
-      <p:sp>
-        <p:nvSpPr>
-          <p:cNvPr id="4" name="Google Shape;72;p14">
-            <a:extLst>
-              <a:ext uri="{FF2B5EF4-FFF2-40B4-BE49-F238E27FC236}">
-                <a16:creationId xmlns:a16="http://schemas.microsoft.com/office/drawing/2014/main" id="{4FBD930A-8BB7-DB84-6591-0DDEF0AB68A9}"/>
-              </a:ext>
-            </a:extLst>
-          </p:cNvPr>
-          <p:cNvSpPr/>
-          <p:nvPr/>
-        </p:nvSpPr>
-        <p:spPr>
-          <a:xfrm>
-            <a:off x="2268872" y="1599750"/>
-            <a:ext cx="278700" cy="212700"/>
-          </a:xfrm>
-          <a:prstGeom prst="rightArrow">
-            <a:avLst>
-              <a:gd name="adj1" fmla="val 50000"/>
-              <a:gd name="adj2" fmla="val 50000"/>
-            </a:avLst>
-          </a:prstGeom>
-          <a:solidFill>
-            <a:schemeClr val="lt2"/>
-          </a:solidFill>
-          <a:ln w="9525" cap="flat" cmpd="sng">
-            <a:solidFill>
-              <a:schemeClr val="dk2"/>
-            </a:solidFill>
-            <a:prstDash val="solid"/>
-            <a:round/>
-            <a:headEnd type="none" w="sm" len="sm"/>
-            <a:tailEnd type="none" w="sm" len="sm"/>
-          </a:ln>
-        </p:spPr>
-        <p:txBody>
-          <a:bodyPr spcFirstLastPara="1" wrap="square" lIns="91425" tIns="91425" rIns="91425" bIns="91425" anchor="ctr" anchorCtr="0">
-            <a:noAutofit/>
-          </a:bodyPr>
-          <a:lstStyle/>
-          <a:p>
-            <a:pPr marL="0" lvl="0" indent="0" algn="ctr" rtl="0">
-              <a:spcBef>
-                <a:spcPts val="0"/>
-              </a:spcBef>
-              <a:spcAft>
-                <a:spcPts val="0"/>
-              </a:spcAft>
-              <a:buNone/>
-            </a:pPr>
-            <a:endParaRPr>
-              <a:latin typeface="Calibri"/>
-              <a:ea typeface="Calibri"/>
-              <a:cs typeface="Calibri"/>
-              <a:sym typeface="Calibri"/>
-            </a:endParaRPr>
-          </a:p>
-        </p:txBody>
-      </p:sp>
-      <p:sp>
-        <p:nvSpPr>
-          <p:cNvPr id="6" name="Google Shape;71;p14">
-            <a:extLst>
-              <a:ext uri="{FF2B5EF4-FFF2-40B4-BE49-F238E27FC236}">
-                <a16:creationId xmlns:a16="http://schemas.microsoft.com/office/drawing/2014/main" id="{DEF1950B-F983-9A41-122E-24CBAF093CF9}"/>
-              </a:ext>
-            </a:extLst>
-          </p:cNvPr>
-          <p:cNvSpPr txBox="1"/>
-          <p:nvPr/>
-        </p:nvSpPr>
-        <p:spPr>
-          <a:xfrm>
-            <a:off x="2683332" y="1429116"/>
-            <a:ext cx="3777336" cy="553968"/>
-          </a:xfrm>
-          <a:prstGeom prst="rect">
-            <a:avLst/>
-          </a:prstGeom>
-          <a:noFill/>
-          <a:ln>
-            <a:noFill/>
-          </a:ln>
-        </p:spPr>
-        <p:txBody>
-          <a:bodyPr spcFirstLastPara="1" wrap="square" lIns="91425" tIns="91425" rIns="91425" bIns="91425" anchor="t" anchorCtr="0">
-            <a:spAutoFit/>
-          </a:bodyPr>
-          <a:lstStyle/>
-          <a:p>
-            <a:pPr lvl="0"/>
-            <a:r>
-              <a:rPr lang="en" altLang="zh-TW" sz="1200" b="1" dirty="0">
-                <a:solidFill>
-                  <a:schemeClr val="dk1"/>
-                </a:solidFill>
-                <a:latin typeface="Calibri"/>
-                <a:ea typeface="Calibri"/>
-                <a:cs typeface="Calibri"/>
-                <a:sym typeface="Calibri"/>
-              </a:rPr>
-              <a:t>lack the ability to perform frame-level fine-grained</a:t>
-            </a:r>
-          </a:p>
-          <a:p>
-            <a:pPr lvl="0"/>
-            <a:r>
-              <a:rPr lang="en" altLang="zh-TW" sz="1200" b="1" dirty="0">
-                <a:solidFill>
-                  <a:schemeClr val="dk1"/>
-                </a:solidFill>
-                <a:latin typeface="Calibri"/>
-                <a:ea typeface="Calibri"/>
-                <a:cs typeface="Calibri"/>
-                <a:sym typeface="Calibri"/>
-              </a:rPr>
-              <a:t>action-conditioned predictions</a:t>
-            </a:r>
-            <a:endParaRPr sz="1200" b="1" dirty="0">
-              <a:solidFill>
-                <a:schemeClr val="dk1"/>
-              </a:solidFill>
-              <a:latin typeface="Calibri"/>
-              <a:ea typeface="Calibri"/>
-              <a:cs typeface="Calibri"/>
-              <a:sym typeface="Calibri"/>
-            </a:endParaRPr>
-          </a:p>
-        </p:txBody>
-      </p:sp>
       <p:sp>
         <p:nvSpPr>
           <p:cNvPr id="7" name="文字方塊 6">
@@ -8065,7 +7665,7 @@
 </file>
 
 <file path=ppt/slides/slide5.xml><?xml version="1.0" encoding="utf-8"?>
-<p:sld xmlns:a="http://schemas.openxmlformats.org/drawingml/2006/main" xmlns:r="http://schemas.openxmlformats.org/officeDocument/2006/relationships" xmlns:p="http://schemas.openxmlformats.org/presentationml/2006/main">
+<p:sld xmlns:a="http://schemas.openxmlformats.org/drawingml/2006/main" xmlns:r="http://schemas.openxmlformats.org/officeDocument/2006/relationships" xmlns:p="http://schemas.openxmlformats.org/presentationml/2006/main" show="0">
   <p:cSld>
     <p:spTree>
       <p:nvGrpSpPr>
@@ -8555,8 +8155,8 @@
         </p:nvSpPr>
         <p:spPr>
           <a:xfrm>
-            <a:off x="-80196" y="662313"/>
-            <a:ext cx="6244721" cy="4481187"/>
+            <a:off x="0" y="864230"/>
+            <a:ext cx="5585340" cy="4062845"/>
           </a:xfrm>
         </p:spPr>
         <p:txBody>
@@ -8618,99 +8218,6 @@
             <a:endParaRPr lang="en" altLang="zh-TW" sz="1600" dirty="0"/>
           </a:p>
           <a:p>
-            <a:pPr>
-              <a:lnSpc>
-                <a:spcPct val="100000"/>
-              </a:lnSpc>
-              <a:buSzPct val="100000"/>
-            </a:pPr>
-            <a:endParaRPr lang="en" altLang="zh-TW" sz="1800" b="1" dirty="0"/>
-          </a:p>
-          <a:p>
-            <a:pPr>
-              <a:lnSpc>
-                <a:spcPct val="100000"/>
-              </a:lnSpc>
-              <a:buSzPct val="100000"/>
-            </a:pPr>
-            <a:r>
-              <a:rPr lang="en" altLang="zh-TW" sz="1800" b="1" dirty="0"/>
-              <a:t>Previous works</a:t>
-            </a:r>
-          </a:p>
-          <a:p>
-            <a:pPr lvl="1">
-              <a:lnSpc>
-                <a:spcPct val="100000"/>
-              </a:lnSpc>
-              <a:buSzPct val="100000"/>
-            </a:pPr>
-            <a:r>
-              <a:rPr lang="en" altLang="zh-TW" sz="1598" b="1" dirty="0">
-                <a:solidFill>
-                  <a:schemeClr val="accent1">
-                    <a:lumMod val="50000"/>
-                  </a:schemeClr>
-                </a:solidFill>
-              </a:rPr>
-              <a:t>Lacks Scene Generalization: </a:t>
-            </a:r>
-            <a:r>
-              <a:rPr lang="en" altLang="zh-TW" sz="1598" dirty="0"/>
-              <a:t>generates specific game, limiting the potential for developing new games</a:t>
-            </a:r>
-          </a:p>
-          <a:p>
-            <a:pPr lvl="1">
-              <a:lnSpc>
-                <a:spcPct val="100000"/>
-              </a:lnSpc>
-              <a:buSzPct val="100000"/>
-            </a:pPr>
-            <a:endParaRPr lang="en" altLang="zh-TW" sz="1598" dirty="0"/>
-          </a:p>
-          <a:p>
-            <a:pPr lvl="1">
-              <a:lnSpc>
-                <a:spcPct val="100000"/>
-              </a:lnSpc>
-              <a:buSzPct val="100000"/>
-            </a:pPr>
-            <a:r>
-              <a:rPr lang="en" altLang="zh-TW" sz="1598" b="1" dirty="0">
-                <a:solidFill>
-                  <a:schemeClr val="accent1">
-                    <a:lumMod val="50000"/>
-                  </a:schemeClr>
-                </a:solidFill>
-              </a:rPr>
-              <a:t>Biased Action:</a:t>
-            </a:r>
-            <a:r>
-              <a:rPr lang="en" altLang="zh-TW" sz="1598" b="1" dirty="0">
-                <a:solidFill>
-                  <a:schemeClr val="tx2">
-                    <a:lumMod val="75000"/>
-                    <a:lumOff val="25000"/>
-                  </a:schemeClr>
-                </a:solidFill>
-              </a:rPr>
-              <a:t> </a:t>
-            </a:r>
-            <a:r>
-              <a:rPr lang="en" altLang="zh-TW" sz="1598" dirty="0"/>
-              <a:t>collecting real human gameplay action, overlooking rare action combinations, such as moving backward</a:t>
-            </a:r>
-            <a:endParaRPr lang="en" altLang="zh-TW" sz="1598" b="1" dirty="0">
-              <a:solidFill>
-                <a:schemeClr val="tx2">
-                  <a:lumMod val="75000"/>
-                  <a:lumOff val="25000"/>
-                </a:schemeClr>
-              </a:solidFill>
-            </a:endParaRPr>
-          </a:p>
-          <a:p>
             <a:pPr marL="622285" lvl="1" indent="0">
               <a:lnSpc>
                 <a:spcPct val="100000"/>
@@ -8789,7 +8296,7 @@
         </p:blipFill>
         <p:spPr>
           <a:xfrm>
-            <a:off x="5430033" y="216426"/>
+            <a:off x="4960800" y="135639"/>
             <a:ext cx="3713967" cy="1790999"/>
           </a:xfrm>
           <a:prstGeom prst="rect">
@@ -9200,7 +8707,7 @@
         </p:nvSpPr>
         <p:spPr>
           <a:xfrm>
-            <a:off x="303261" y="923875"/>
+            <a:off x="74189" y="672415"/>
             <a:ext cx="5390174" cy="4003200"/>
           </a:xfrm>
         </p:spPr>
@@ -9265,15 +8772,6 @@
               <a:rPr lang="en-US" altLang="zh-TW" sz="1600" dirty="0"/>
               <a:t>Avoid mismatch between action and latent</a:t>
             </a:r>
-          </a:p>
-          <a:p>
-            <a:pPr lvl="1">
-              <a:lnSpc>
-                <a:spcPct val="100000"/>
-              </a:lnSpc>
-              <a:buSzPct val="100000"/>
-            </a:pPr>
-            <a:endParaRPr lang="en-US" altLang="zh-TW" sz="1600" dirty="0"/>
           </a:p>
           <a:p>
             <a:pPr lvl="1">
@@ -9339,7 +8837,7 @@
         </p:blipFill>
         <p:spPr>
           <a:xfrm>
-            <a:off x="5490549" y="0"/>
+            <a:off x="476107" y="2571750"/>
             <a:ext cx="3203531" cy="2571750"/>
           </a:xfrm>
           <a:prstGeom prst="rect">
@@ -9453,8 +8951,8 @@
           </a:p>
         </p:txBody>
       </p:sp>
-      <mc:AlternateContent xmlns:mc="http://schemas.openxmlformats.org/markup-compatibility/2006">
-        <mc:Choice xmlns:a14="http://schemas.microsoft.com/office/drawing/2010/main" Requires="a14">
+      <mc:AlternateContent xmlns:mc="http://schemas.openxmlformats.org/markup-compatibility/2006" xmlns:a14="http://schemas.microsoft.com/office/drawing/2010/main">
+        <mc:Choice Requires="a14">
           <p:sp>
             <p:nvSpPr>
               <p:cNvPr id="3" name="文字版面配置區 2">
@@ -9757,7 +9255,7 @@
             </p:txBody>
           </p:sp>
         </mc:Choice>
-        <mc:Fallback>
+        <mc:Fallback xmlns="">
           <p:sp>
             <p:nvSpPr>
               <p:cNvPr id="3" name="文字版面配置區 2">

</xml_diff>